<commit_message>
docs: 按 PR #33 review 修正交付材料 (#7)
- 项目介绍：本地核验只在确认页；原文件下载才校验成员身份（更正
  「里程碑详情也限成员」的错误说法）；课程名改为「课程综合实践Ⅱ」
- PPT：第 4 页 txId 说法、第 9 页响应式说法与实际一致；截图裁掉侧栏
  并放大，标签移到截图上方；第 2、3 页卡片文字顶部对齐；去掉私有仓库
  地址；第 1–4 页备注换成杨宇的讲稿（#35）
- 打分表：表头「参考分」改为「评分」，补记杨宇对 PR #33 的 review；
  重新生成两份 Word

Co-Authored-By: Claude Opus 5.5 <noreply@anthropic.com>
</commit_message>
<xml_diff>
--- a/docs/defense/ChainProof-答辩.pptx
+++ b/docs/defense/ChainProof-答辩.pptx
@@ -515,7 +515,7 @@
             <a:r>
               <a:rPr lang="en-US" dirty="0"/>
               <a:t>【主讲】杨宇　【建议时长】0:10
-「大家好，我们是 ChainProof 组，作品是基于 Hyperledger Fabric 的团队成果与贡献可信存证平台。」介绍三位成员分工。</a:t>
+大家好，我们是 ChainProof 组，作品是一个基于 Hyperledger Fabric 的团队贡献存证平台。组长全书阅做后端和集成，黄铭谦做区块链和智能合约，我是杨宇，做前端和产品。</a:t>
             </a:r>
             <a:endParaRPr lang="en-US" dirty="0"/>
           </a:p>
@@ -960,7 +960,7 @@
             <a:r>
               <a:rPr lang="en-US" dirty="0"/>
               <a:t>【主讲】杨宇　【建议时长】0:30
-从大家都经历过的小组作业讲起：贡献争议的根源是缺乏「多方认可、不可单方修改、能和文件绑定」的过程记录。现有工具各缺一块，联盟链正好适合多方共同认可的记录。</a:t>
+做过小组作业的都知道，最难说清的是谁做了什么。比例常常在结束时凭回忆定，贡献表一方事后就能改，老师拿到一份说明也没法自己核实。现有的工具各缺一块：Git 只管代码，共享表格管理员一个人能改，纸面签字和文件对不上。所以我们把成果文件、贡献比例和其他成员的确认一起存到联盟链上，再生成任何人都能核验的贡献证明。</a:t>
             </a:r>
             <a:endParaRPr lang="en-US" dirty="0"/>
           </a:p>
@@ -1049,7 +1049,7 @@
             <a:r>
               <a:rPr lang="en-US" dirty="0"/>
               <a:t>【主讲】杨宇　【建议时长】0:25
-强调实用价值：凡是多人协作、需要事后说明贡献的场合都能用。外部验证者不需要账号，这是证明能「拿出去用」的关键。</a:t>
+凡是事后要说明贡献的合作都能用：课程作业、竞赛、科研合作，还有求职时附在简历上。用户分三类：负责人建项目、登记成员；成员提交成果，互相核验确认；外部的老师、评委、用人单位不用注册，凭证书编号就能核验（这一点决定了证明能拿出去用）。</a:t>
             </a:r>
             <a:endParaRPr lang="en-US" dirty="0"/>
           </a:p>
@@ -1138,7 +1138,7 @@
             <a:r>
               <a:rPr lang="en-US" dirty="0"/>
               <a:t>【主讲】杨宇　【建议时长】0:25
-用五步讲清产品怎么用，第 3 步「其他成员核验并确认」是和普通存证系统最大的不同，后面技术部分会展开。讲完交给黄铭谦。</a:t>
+用起来是五步：负责人建项目；成员上传成果文件，声明贡献比例；其他成员下载原文件，在浏览器里核对哈希，再确认或拒绝；全员确认后记录变成已验证，计入统计；最后签发证明，公开验证。第三步是和普通存证系统最大的不同，下面请黄铭谦讲它是怎么做到的。</a:t>
             </a:r>
             <a:endParaRPr lang="en-US" dirty="0"/>
           </a:p>
@@ -1989,7 +1989,7 @@
                 <a:ea typeface="Microsoft YaHei" pitchFamily="34" charset="-122"/>
                 <a:cs typeface="Microsoft YaHei" pitchFamily="34" charset="-120"/>
               </a:rPr>
-              <a:t>区块链技术应用实践 · 课程大作业　|　ChainProof 组</a:t>
+              <a:t>课程综合实践Ⅱ · 区块链技术应用实践大作业　|　ChainProof 组</a:t>
             </a:r>
             <a:endParaRPr lang="en-US" sz="1600" dirty="0"/>
           </a:p>
@@ -5026,45 +5026,6 @@
           </a:p>
         </p:txBody>
       </p:sp>
-      <p:sp>
-        <p:nvSpPr>
-          <p:cNvPr id="5" name="Text 3"/>
-          <p:cNvSpPr/>
-          <p:nvPr/>
-        </p:nvSpPr>
-        <p:spPr>
-          <a:xfrm>
-            <a:off x="822960" y="5166360"/>
-            <a:ext cx="7315200" cy="365760"/>
-          </a:xfrm>
-          <a:prstGeom prst="rect">
-            <a:avLst/>
-          </a:prstGeom>
-          <a:noFill/>
-          <a:ln/>
-        </p:spPr>
-        <p:txBody>
-          <a:bodyPr wrap="square" rtlCol="0" anchor="ctr"/>
-          <a:lstStyle/>
-          <a:p>
-            <a:pPr indent="0" marL="0">
-              <a:buNone/>
-            </a:pPr>
-            <a:r>
-              <a:rPr lang="en-US" sz="1400" dirty="0">
-                <a:solidFill>
-                  <a:srgbClr val="C7CAF5"/>
-                </a:solidFill>
-                <a:latin typeface="Consolas" pitchFamily="34" charset="0"/>
-                <a:ea typeface="Consolas" pitchFamily="34" charset="-122"/>
-                <a:cs typeface="Consolas" pitchFamily="34" charset="-120"/>
-              </a:rPr>
-              <a:t>github.com/Looffeeuu/ChainProof</a:t>
-            </a:r>
-            <a:endParaRPr lang="en-US" sz="1400" dirty="0"/>
-          </a:p>
-        </p:txBody>
-      </p:sp>
     </p:spTree>
   </p:cSld>
   <p:clrMapOvr>
@@ -5889,17 +5850,17 @@
         </p:nvSpPr>
         <p:spPr>
           <a:xfrm>
-            <a:off x="914400" y="4114800"/>
-            <a:ext cx="3200400" cy="868680"/>
-          </a:xfrm>
-          <a:prstGeom prst="rect">
-            <a:avLst/>
-          </a:prstGeom>
-          <a:noFill/>
-          <a:ln/>
-        </p:spPr>
-        <p:txBody>
-          <a:bodyPr wrap="square" rtlCol="0" anchor="ctr"/>
+            <a:off x="914400" y="4187952"/>
+            <a:ext cx="3200400" cy="777240"/>
+          </a:xfrm>
+          <a:prstGeom prst="rect">
+            <a:avLst/>
+          </a:prstGeom>
+          <a:noFill/>
+          <a:ln/>
+        </p:spPr>
+        <p:txBody>
+          <a:bodyPr wrap="square" rtlCol="0" anchor="t"/>
           <a:lstStyle/>
           <a:p>
             <a:pPr indent="0" marL="0">
@@ -5970,17 +5931,17 @@
         </p:nvSpPr>
         <p:spPr>
           <a:xfrm>
-            <a:off x="4617720" y="4114800"/>
-            <a:ext cx="3200400" cy="868680"/>
-          </a:xfrm>
-          <a:prstGeom prst="rect">
-            <a:avLst/>
-          </a:prstGeom>
-          <a:noFill/>
-          <a:ln/>
-        </p:spPr>
-        <p:txBody>
-          <a:bodyPr wrap="square" rtlCol="0" anchor="ctr"/>
+            <a:off x="4617720" y="4187952"/>
+            <a:ext cx="3200400" cy="777240"/>
+          </a:xfrm>
+          <a:prstGeom prst="rect">
+            <a:avLst/>
+          </a:prstGeom>
+          <a:noFill/>
+          <a:ln/>
+        </p:spPr>
+        <p:txBody>
+          <a:bodyPr wrap="square" rtlCol="0" anchor="t"/>
           <a:lstStyle/>
           <a:p>
             <a:pPr indent="0" marL="0">
@@ -6051,17 +6012,17 @@
         </p:nvSpPr>
         <p:spPr>
           <a:xfrm>
-            <a:off x="8321040" y="4114800"/>
-            <a:ext cx="3200400" cy="868680"/>
-          </a:xfrm>
-          <a:prstGeom prst="rect">
-            <a:avLst/>
-          </a:prstGeom>
-          <a:noFill/>
-          <a:ln/>
-        </p:spPr>
-        <p:txBody>
-          <a:bodyPr wrap="square" rtlCol="0" anchor="ctr"/>
+            <a:off x="8321040" y="4187952"/>
+            <a:ext cx="3200400" cy="777240"/>
+          </a:xfrm>
+          <a:prstGeom prst="rect">
+            <a:avLst/>
+          </a:prstGeom>
+          <a:noFill/>
+          <a:ln/>
+        </p:spPr>
+        <p:txBody>
+          <a:bodyPr wrap="square" rtlCol="0" anchor="t"/>
           <a:lstStyle/>
           <a:p>
             <a:pPr indent="0" marL="0">
@@ -7001,17 +6962,17 @@
         </p:nvSpPr>
         <p:spPr>
           <a:xfrm>
-            <a:off x="914400" y="4663440"/>
-            <a:ext cx="3154680" cy="1417320"/>
-          </a:xfrm>
-          <a:prstGeom prst="rect">
-            <a:avLst/>
-          </a:prstGeom>
-          <a:noFill/>
-          <a:ln/>
-        </p:spPr>
-        <p:txBody>
-          <a:bodyPr wrap="square" rtlCol="0" anchor="ctr"/>
+            <a:off x="914400" y="4800600"/>
+            <a:ext cx="3154680" cy="1234440"/>
+          </a:xfrm>
+          <a:prstGeom prst="rect">
+            <a:avLst/>
+          </a:prstGeom>
+          <a:noFill/>
+          <a:ln/>
+        </p:spPr>
+        <p:txBody>
+          <a:bodyPr wrap="square" rtlCol="0" anchor="t"/>
           <a:lstStyle/>
           <a:p>
             <a:pPr indent="0" marL="0">
@@ -7082,17 +7043,17 @@
         </p:nvSpPr>
         <p:spPr>
           <a:xfrm>
-            <a:off x="4617720" y="4663440"/>
-            <a:ext cx="3154680" cy="1417320"/>
-          </a:xfrm>
-          <a:prstGeom prst="rect">
-            <a:avLst/>
-          </a:prstGeom>
-          <a:noFill/>
-          <a:ln/>
-        </p:spPr>
-        <p:txBody>
-          <a:bodyPr wrap="square" rtlCol="0" anchor="ctr"/>
+            <a:off x="4617720" y="4800600"/>
+            <a:ext cx="3154680" cy="1234440"/>
+          </a:xfrm>
+          <a:prstGeom prst="rect">
+            <a:avLst/>
+          </a:prstGeom>
+          <a:noFill/>
+          <a:ln/>
+        </p:spPr>
+        <p:txBody>
+          <a:bodyPr wrap="square" rtlCol="0" anchor="t"/>
           <a:lstStyle/>
           <a:p>
             <a:pPr indent="0" marL="0">
@@ -7163,17 +7124,17 @@
         </p:nvSpPr>
         <p:spPr>
           <a:xfrm>
-            <a:off x="8321040" y="4663440"/>
-            <a:ext cx="3154680" cy="1417320"/>
-          </a:xfrm>
-          <a:prstGeom prst="rect">
-            <a:avLst/>
-          </a:prstGeom>
-          <a:noFill/>
-          <a:ln/>
-        </p:spPr>
-        <p:txBody>
-          <a:bodyPr wrap="square" rtlCol="0" anchor="ctr"/>
+            <a:off x="8321040" y="4800600"/>
+            <a:ext cx="3154680" cy="1234440"/>
+          </a:xfrm>
+          <a:prstGeom prst="rect">
+            <a:avLst/>
+          </a:prstGeom>
+          <a:noFill/>
+          <a:ln/>
+        </p:spPr>
+        <p:txBody>
+          <a:bodyPr wrap="square" rtlCol="0" anchor="t"/>
           <a:lstStyle/>
           <a:p>
             <a:pPr indent="0" marL="0">
@@ -8561,7 +8522,7 @@
                 <a:ea typeface="Microsoft YaHei" pitchFamily="34" charset="-122"/>
                 <a:cs typeface="Microsoft YaHei" pitchFamily="34" charset="-120"/>
               </a:rPr>
-              <a:t>每一步状态变化都是一笔 Fabric 交易，页面上直接展示对应的 txId</a:t>
+              <a:t>提交、确认、签发都是 Fabric 交易，里程碑和证书上能看到对应的 txId</a:t>
             </a:r>
             <a:endParaRPr lang="en-US" sz="1500" dirty="0"/>
           </a:p>
@@ -9892,7 +9853,7 @@
       </p:sp>
       <p:pic>
         <p:nvPicPr>
-          <p:cNvPr id="7" name="Image 0" descr="docs/defense/screenshots/confirm.png">    </p:cNvPr>
+          <p:cNvPr id="7" name="Image 0" descr="docs/defense/screenshots/crop-confirm.png">    </p:cNvPr>
           <p:cNvPicPr>
             <a:picLocks noChangeAspect="1"/>
           </p:cNvPicPr>
@@ -9906,8 +9867,8 @@
         </p:blipFill>
         <p:spPr>
           <a:xfrm>
-            <a:off x="5943600" y="1645920"/>
-            <a:ext cx="5760720" cy="3600450"/>
+            <a:off x="5852160" y="1685925"/>
+            <a:ext cx="5806440" cy="4354830"/>
           </a:xfrm>
           <a:prstGeom prst="rect">
             <a:avLst/>
@@ -9922,8 +9883,8 @@
         </p:nvSpPr>
         <p:spPr>
           <a:xfrm>
-            <a:off x="5943600" y="1645920"/>
-            <a:ext cx="5760720" cy="3600450"/>
+            <a:off x="5852160" y="1685925"/>
+            <a:ext cx="5806440" cy="4354830"/>
           </a:xfrm>
           <a:prstGeom prst="rect">
             <a:avLst/>
@@ -13240,9 +13201,48 @@
           </a:p>
         </p:txBody>
       </p:sp>
+      <p:sp>
+        <p:nvSpPr>
+          <p:cNvPr id="6" name="Text 4"/>
+          <p:cNvSpPr/>
+          <p:nvPr/>
+        </p:nvSpPr>
+        <p:spPr>
+          <a:xfrm>
+            <a:off x="731520" y="1463040"/>
+            <a:ext cx="5394960" cy="320040"/>
+          </a:xfrm>
+          <a:prstGeom prst="rect">
+            <a:avLst/>
+          </a:prstGeom>
+          <a:noFill/>
+          <a:ln/>
+        </p:spPr>
+        <p:txBody>
+          <a:bodyPr wrap="square" rtlCol="0" anchor="ctr"/>
+          <a:lstStyle/>
+          <a:p>
+            <a:pPr indent="0" marL="0">
+              <a:buNone/>
+            </a:pPr>
+            <a:r>
+              <a:rPr lang="en-US" sz="1300" b="1" dirty="0">
+                <a:solidFill>
+                  <a:srgbClr val="3438C8"/>
+                </a:solidFill>
+                <a:latin typeface="Microsoft YaHei" pitchFamily="34" charset="0"/>
+                <a:ea typeface="Microsoft YaHei" pitchFamily="34" charset="-122"/>
+                <a:cs typeface="Microsoft YaHei" pitchFamily="34" charset="-120"/>
+              </a:rPr>
+              <a:t>概览：项目、已验证里程碑、最近活动</a:t>
+            </a:r>
+            <a:endParaRPr lang="en-US" sz="1300" dirty="0"/>
+          </a:p>
+        </p:txBody>
+      </p:sp>
       <p:pic>
         <p:nvPicPr>
-          <p:cNvPr id="6" name="Image 0" descr="docs/defense/screenshots/dashboard.png">    </p:cNvPr>
+          <p:cNvPr id="7" name="Image 0" descr="docs/defense/screenshots/crop-dashboard.png">    </p:cNvPr>
           <p:cNvPicPr>
             <a:picLocks noChangeAspect="1"/>
           </p:cNvPicPr>
@@ -13256,8 +13256,8 @@
         </p:blipFill>
         <p:spPr>
           <a:xfrm>
-            <a:off x="731520" y="1508760"/>
-            <a:ext cx="3611880" cy="2257425"/>
+            <a:off x="731520" y="1828800"/>
+            <a:ext cx="4760876" cy="1828800"/>
           </a:xfrm>
           <a:prstGeom prst="rect">
             <a:avLst/>
@@ -13266,14 +13266,14 @@
       </p:pic>
       <p:sp>
         <p:nvSpPr>
-          <p:cNvPr id="7" name="Shape 4"/>
-          <p:cNvSpPr/>
-          <p:nvPr/>
-        </p:nvSpPr>
-        <p:spPr>
-          <a:xfrm>
-            <a:off x="731520" y="1508760"/>
-            <a:ext cx="3611880" cy="2257425"/>
+          <p:cNvPr id="8" name="Shape 5"/>
+          <p:cNvSpPr/>
+          <p:nvPr/>
+        </p:nvSpPr>
+        <p:spPr>
+          <a:xfrm>
+            <a:off x="731520" y="1828800"/>
+            <a:ext cx="4760876" cy="1828800"/>
           </a:xfrm>
           <a:prstGeom prst="rect">
             <a:avLst/>
@@ -13293,53 +13293,26 @@
       </p:sp>
       <p:sp>
         <p:nvSpPr>
-          <p:cNvPr id="8" name="Shape 5"/>
-          <p:cNvSpPr/>
-          <p:nvPr/>
-        </p:nvSpPr>
-        <p:spPr>
-          <a:xfrm>
-            <a:off x="841248" y="3272409"/>
-            <a:ext cx="1188720" cy="384048"/>
-          </a:xfrm>
-          <a:prstGeom prst="roundRect">
-            <a:avLst>
-              <a:gd name="adj" fmla="val 50000"/>
-            </a:avLst>
-          </a:prstGeom>
-          <a:solidFill>
-            <a:srgbClr val="FFFFFF"/>
-          </a:solidFill>
-          <a:ln w="12700">
-            <a:solidFill>
-              <a:srgbClr val="3438C8"/>
-            </a:solidFill>
-            <a:prstDash val="solid"/>
-          </a:ln>
-        </p:spPr>
-      </p:sp>
-      <p:sp>
-        <p:nvSpPr>
           <p:cNvPr id="9" name="Text 6"/>
           <p:cNvSpPr/>
           <p:nvPr/>
         </p:nvSpPr>
         <p:spPr>
           <a:xfrm>
-            <a:off x="841248" y="3272409"/>
-            <a:ext cx="1188720" cy="384048"/>
-          </a:xfrm>
-          <a:prstGeom prst="rect">
-            <a:avLst/>
-          </a:prstGeom>
-          <a:noFill/>
-          <a:ln/>
-        </p:spPr>
-        <p:txBody>
-          <a:bodyPr wrap="square" rtlCol="0" anchor="ctr"/>
-          <a:lstStyle/>
-          <a:p>
-            <a:pPr algn="ctr" indent="0" marL="0">
+            <a:off x="6263640" y="1463040"/>
+            <a:ext cx="5394960" cy="320040"/>
+          </a:xfrm>
+          <a:prstGeom prst="rect">
+            <a:avLst/>
+          </a:prstGeom>
+          <a:noFill/>
+          <a:ln/>
+        </p:spPr>
+        <p:txBody>
+          <a:bodyPr wrap="square" rtlCol="0" anchor="ctr"/>
+          <a:lstStyle/>
+          <a:p>
+            <a:pPr indent="0" marL="0">
               <a:buNone/>
             </a:pPr>
             <a:r>
@@ -13351,7 +13324,7 @@
                 <a:ea typeface="Microsoft YaHei" pitchFamily="34" charset="-122"/>
                 <a:cs typeface="Microsoft YaHei" pitchFamily="34" charset="-120"/>
               </a:rPr>
-              <a:t>概览</a:t>
+              <a:t>项目详情：累计贡献与存证概况</a:t>
             </a:r>
             <a:endParaRPr lang="en-US" sz="1300" dirty="0"/>
           </a:p>
@@ -13359,7 +13332,7 @@
       </p:sp>
       <p:pic>
         <p:nvPicPr>
-          <p:cNvPr id="10" name="Image 1" descr="docs/defense/screenshots/project.png">    </p:cNvPr>
+          <p:cNvPr id="10" name="Image 1" descr="docs/defense/screenshots/crop-project.png">    </p:cNvPr>
           <p:cNvPicPr>
             <a:picLocks noChangeAspect="1"/>
           </p:cNvPicPr>
@@ -13373,8 +13346,8 @@
         </p:blipFill>
         <p:spPr>
           <a:xfrm>
-            <a:off x="4526280" y="1508760"/>
-            <a:ext cx="3611880" cy="2257425"/>
+            <a:off x="6263640" y="1828800"/>
+            <a:ext cx="4889115" cy="1828800"/>
           </a:xfrm>
           <a:prstGeom prst="rect">
             <a:avLst/>
@@ -13389,8 +13362,8 @@
         </p:nvSpPr>
         <p:spPr>
           <a:xfrm>
-            <a:off x="4526280" y="1508760"/>
-            <a:ext cx="3611880" cy="2257425"/>
+            <a:off x="6263640" y="1828800"/>
+            <a:ext cx="4889115" cy="1828800"/>
           </a:xfrm>
           <a:prstGeom prst="rect">
             <a:avLst/>
@@ -13410,53 +13383,26 @@
       </p:sp>
       <p:sp>
         <p:nvSpPr>
-          <p:cNvPr id="12" name="Shape 8"/>
-          <p:cNvSpPr/>
-          <p:nvPr/>
-        </p:nvSpPr>
-        <p:spPr>
-          <a:xfrm>
-            <a:off x="4636008" y="3272409"/>
-            <a:ext cx="1188720" cy="384048"/>
-          </a:xfrm>
-          <a:prstGeom prst="roundRect">
-            <a:avLst>
-              <a:gd name="adj" fmla="val 50000"/>
-            </a:avLst>
-          </a:prstGeom>
-          <a:solidFill>
-            <a:srgbClr val="FFFFFF"/>
-          </a:solidFill>
-          <a:ln w="12700">
-            <a:solidFill>
-              <a:srgbClr val="3438C8"/>
-            </a:solidFill>
-            <a:prstDash val="solid"/>
-          </a:ln>
-        </p:spPr>
-      </p:sp>
-      <p:sp>
-        <p:nvSpPr>
-          <p:cNvPr id="13" name="Text 9"/>
-          <p:cNvSpPr/>
-          <p:nvPr/>
-        </p:nvSpPr>
-        <p:spPr>
-          <a:xfrm>
-            <a:off x="4636008" y="3272409"/>
-            <a:ext cx="1188720" cy="384048"/>
-          </a:xfrm>
-          <a:prstGeom prst="rect">
-            <a:avLst/>
-          </a:prstGeom>
-          <a:noFill/>
-          <a:ln/>
-        </p:spPr>
-        <p:txBody>
-          <a:bodyPr wrap="square" rtlCol="0" anchor="ctr"/>
-          <a:lstStyle/>
-          <a:p>
-            <a:pPr algn="ctr" indent="0" marL="0">
+          <p:cNvPr id="12" name="Text 8"/>
+          <p:cNvSpPr/>
+          <p:nvPr/>
+        </p:nvSpPr>
+        <p:spPr>
+          <a:xfrm>
+            <a:off x="731520" y="3749040"/>
+            <a:ext cx="5394960" cy="320040"/>
+          </a:xfrm>
+          <a:prstGeom prst="rect">
+            <a:avLst/>
+          </a:prstGeom>
+          <a:noFill/>
+          <a:ln/>
+        </p:spPr>
+        <p:txBody>
+          <a:bodyPr wrap="square" rtlCol="0" anchor="ctr"/>
+          <a:lstStyle/>
+          <a:p>
+            <a:pPr indent="0" marL="0">
               <a:buNone/>
             </a:pPr>
             <a:r>
@@ -13468,7 +13414,7 @@
                 <a:ea typeface="Microsoft YaHei" pitchFamily="34" charset="-122"/>
                 <a:cs typeface="Microsoft YaHei" pitchFamily="34" charset="-120"/>
               </a:rPr>
-              <a:t>项目详情</a:t>
+              <a:t>贡献证书</a:t>
             </a:r>
             <a:endParaRPr lang="en-US" sz="1300" dirty="0"/>
           </a:p>
@@ -13476,7 +13422,7 @@
       </p:sp>
       <p:pic>
         <p:nvPicPr>
-          <p:cNvPr id="14" name="Image 2" descr="docs/defense/screenshots/certificate.png">    </p:cNvPr>
+          <p:cNvPr id="13" name="Image 2" descr="docs/defense/screenshots/crop-certificate.png">    </p:cNvPr>
           <p:cNvPicPr>
             <a:picLocks noChangeAspect="1"/>
           </p:cNvPicPr>
@@ -13490,8 +13436,8 @@
         </p:blipFill>
         <p:spPr>
           <a:xfrm>
-            <a:off x="731520" y="3931920"/>
-            <a:ext cx="3611880" cy="2257425"/>
+            <a:off x="731520" y="4114800"/>
+            <a:ext cx="2567950" cy="1828800"/>
           </a:xfrm>
           <a:prstGeom prst="rect">
             <a:avLst/>
@@ -13500,14 +13446,14 @@
       </p:pic>
       <p:sp>
         <p:nvSpPr>
-          <p:cNvPr id="15" name="Shape 10"/>
-          <p:cNvSpPr/>
-          <p:nvPr/>
-        </p:nvSpPr>
-        <p:spPr>
-          <a:xfrm>
-            <a:off x="731520" y="3931920"/>
-            <a:ext cx="3611880" cy="2257425"/>
+          <p:cNvPr id="14" name="Shape 9"/>
+          <p:cNvSpPr/>
+          <p:nvPr/>
+        </p:nvSpPr>
+        <p:spPr>
+          <a:xfrm>
+            <a:off x="731520" y="4114800"/>
+            <a:ext cx="2567950" cy="1828800"/>
           </a:xfrm>
           <a:prstGeom prst="rect">
             <a:avLst/>
@@ -13527,53 +13473,26 @@
       </p:sp>
       <p:sp>
         <p:nvSpPr>
-          <p:cNvPr id="16" name="Shape 11"/>
-          <p:cNvSpPr/>
-          <p:nvPr/>
-        </p:nvSpPr>
-        <p:spPr>
-          <a:xfrm>
-            <a:off x="841248" y="5695569"/>
-            <a:ext cx="1188720" cy="384048"/>
-          </a:xfrm>
-          <a:prstGeom prst="roundRect">
-            <a:avLst>
-              <a:gd name="adj" fmla="val 50000"/>
-            </a:avLst>
-          </a:prstGeom>
-          <a:solidFill>
-            <a:srgbClr val="FFFFFF"/>
-          </a:solidFill>
-          <a:ln w="12700">
-            <a:solidFill>
-              <a:srgbClr val="3438C8"/>
-            </a:solidFill>
-            <a:prstDash val="solid"/>
-          </a:ln>
-        </p:spPr>
-      </p:sp>
-      <p:sp>
-        <p:nvSpPr>
-          <p:cNvPr id="17" name="Text 12"/>
-          <p:cNvSpPr/>
-          <p:nvPr/>
-        </p:nvSpPr>
-        <p:spPr>
-          <a:xfrm>
-            <a:off x="841248" y="5695569"/>
-            <a:ext cx="1188720" cy="384048"/>
-          </a:xfrm>
-          <a:prstGeom prst="rect">
-            <a:avLst/>
-          </a:prstGeom>
-          <a:noFill/>
-          <a:ln/>
-        </p:spPr>
-        <p:txBody>
-          <a:bodyPr wrap="square" rtlCol="0" anchor="ctr"/>
-          <a:lstStyle/>
-          <a:p>
-            <a:pPr algn="ctr" indent="0" marL="0">
+          <p:cNvPr id="15" name="Text 10"/>
+          <p:cNvSpPr/>
+          <p:nvPr/>
+        </p:nvSpPr>
+        <p:spPr>
+          <a:xfrm>
+            <a:off x="6263640" y="3749040"/>
+            <a:ext cx="5394960" cy="320040"/>
+          </a:xfrm>
+          <a:prstGeom prst="rect">
+            <a:avLst/>
+          </a:prstGeom>
+          <a:noFill/>
+          <a:ln/>
+        </p:spPr>
+        <p:txBody>
+          <a:bodyPr wrap="square" rtlCol="0" anchor="ctr"/>
+          <a:lstStyle/>
+          <a:p>
+            <a:pPr indent="0" marL="0">
               <a:buNone/>
             </a:pPr>
             <a:r>
@@ -13585,7 +13504,7 @@
                 <a:ea typeface="Microsoft YaHei" pitchFamily="34" charset="-122"/>
                 <a:cs typeface="Microsoft YaHei" pitchFamily="34" charset="-120"/>
               </a:rPr>
-              <a:t>贡献证书</a:t>
+              <a:t>公开验证：无需登录</a:t>
             </a:r>
             <a:endParaRPr lang="en-US" sz="1300" dirty="0"/>
           </a:p>
@@ -13593,7 +13512,7 @@
       </p:sp>
       <p:pic>
         <p:nvPicPr>
-          <p:cNvPr id="18" name="Image 3" descr="docs/defense/screenshots/verify.png">    </p:cNvPr>
+          <p:cNvPr id="16" name="Image 3" descr="docs/defense/screenshots/crop-verify.png">    </p:cNvPr>
           <p:cNvPicPr>
             <a:picLocks noChangeAspect="1"/>
           </p:cNvPicPr>
@@ -13607,8 +13526,8 @@
         </p:blipFill>
         <p:spPr>
           <a:xfrm>
-            <a:off x="4526280" y="3931920"/>
-            <a:ext cx="3611880" cy="2257425"/>
+            <a:off x="6263640" y="4114800"/>
+            <a:ext cx="2535442" cy="1828800"/>
           </a:xfrm>
           <a:prstGeom prst="rect">
             <a:avLst/>
@@ -13617,14 +13536,14 @@
       </p:pic>
       <p:sp>
         <p:nvSpPr>
-          <p:cNvPr id="19" name="Shape 13"/>
-          <p:cNvSpPr/>
-          <p:nvPr/>
-        </p:nvSpPr>
-        <p:spPr>
-          <a:xfrm>
-            <a:off x="4526280" y="3931920"/>
-            <a:ext cx="3611880" cy="2257425"/>
+          <p:cNvPr id="17" name="Shape 11"/>
+          <p:cNvSpPr/>
+          <p:nvPr/>
+        </p:nvSpPr>
+        <p:spPr>
+          <a:xfrm>
+            <a:off x="6263640" y="4114800"/>
+            <a:ext cx="2535442" cy="1828800"/>
           </a:xfrm>
           <a:prstGeom prst="rect">
             <a:avLst/>
@@ -13644,236 +13563,40 @@
       </p:sp>
       <p:sp>
         <p:nvSpPr>
-          <p:cNvPr id="20" name="Shape 14"/>
-          <p:cNvSpPr/>
-          <p:nvPr/>
-        </p:nvSpPr>
-        <p:spPr>
-          <a:xfrm>
-            <a:off x="4636008" y="5695569"/>
-            <a:ext cx="1188720" cy="384048"/>
-          </a:xfrm>
-          <a:prstGeom prst="roundRect">
-            <a:avLst>
-              <a:gd name="adj" fmla="val 50000"/>
-            </a:avLst>
-          </a:prstGeom>
-          <a:solidFill>
-            <a:srgbClr val="FFFFFF"/>
-          </a:solidFill>
-          <a:ln w="12700">
-            <a:solidFill>
-              <a:srgbClr val="3438C8"/>
-            </a:solidFill>
-            <a:prstDash val="solid"/>
-          </a:ln>
-        </p:spPr>
-      </p:sp>
-      <p:sp>
-        <p:nvSpPr>
-          <p:cNvPr id="21" name="Text 15"/>
-          <p:cNvSpPr/>
-          <p:nvPr/>
-        </p:nvSpPr>
-        <p:spPr>
-          <a:xfrm>
-            <a:off x="4636008" y="5695569"/>
-            <a:ext cx="1188720" cy="384048"/>
-          </a:xfrm>
-          <a:prstGeom prst="rect">
-            <a:avLst/>
-          </a:prstGeom>
-          <a:noFill/>
-          <a:ln/>
-        </p:spPr>
-        <p:txBody>
-          <a:bodyPr wrap="square" rtlCol="0" anchor="ctr"/>
-          <a:lstStyle/>
-          <a:p>
-            <a:pPr algn="ctr" indent="0" marL="0">
-              <a:buNone/>
-            </a:pPr>
-            <a:r>
-              <a:rPr lang="en-US" sz="1300" b="1" dirty="0">
-                <a:solidFill>
-                  <a:srgbClr val="3438C8"/>
-                </a:solidFill>
-                <a:latin typeface="Microsoft YaHei" pitchFamily="34" charset="0"/>
-                <a:ea typeface="Microsoft YaHei" pitchFamily="34" charset="-122"/>
-                <a:cs typeface="Microsoft YaHei" pitchFamily="34" charset="-120"/>
-              </a:rPr>
-              <a:t>公开验证</a:t>
+          <p:cNvPr id="18" name="Text 12"/>
+          <p:cNvSpPr/>
+          <p:nvPr/>
+        </p:nvSpPr>
+        <p:spPr>
+          <a:xfrm>
+            <a:off x="731520" y="5989320"/>
+            <a:ext cx="10972800" cy="365760"/>
+          </a:xfrm>
+          <a:prstGeom prst="rect">
+            <a:avLst/>
+          </a:prstGeom>
+          <a:noFill/>
+          <a:ln/>
+        </p:spPr>
+        <p:txBody>
+          <a:bodyPr wrap="square" rtlCol="0" anchor="ctr"/>
+          <a:lstStyle/>
+          <a:p>
+            <a:pPr indent="0" marL="0">
+              <a:buNone/>
+            </a:pPr>
+            <a:r>
+              <a:rPr lang="en-US" sz="1300" dirty="0">
+                <a:solidFill>
+                  <a:srgbClr val="475569"/>
+                </a:solidFill>
+                <a:latin typeface="Microsoft YaHei" pitchFamily="34" charset="0"/>
+                <a:ea typeface="Microsoft YaHei" pitchFamily="34" charset="-122"/>
+                <a:cs typeface="Microsoft YaHei" pitchFamily="34" charset="-120"/>
+              </a:rPr>
+              <a:t>统一设计令牌与组件库 · 亮 / 暗两套主题 · 窄到 375 px 手机宽也不出横向滚动 · 错误逐块降级 · 15 组前端自检</a:t>
             </a:r>
             <a:endParaRPr lang="en-US" sz="1300" dirty="0"/>
-          </a:p>
-        </p:txBody>
-      </p:sp>
-      <p:sp>
-        <p:nvSpPr>
-          <p:cNvPr id="22" name="Shape 16"/>
-          <p:cNvSpPr/>
-          <p:nvPr/>
-        </p:nvSpPr>
-        <p:spPr>
-          <a:xfrm>
-            <a:off x="8458200" y="1508760"/>
-            <a:ext cx="3200400" cy="4663440"/>
-          </a:xfrm>
-          <a:prstGeom prst="roundRect">
-            <a:avLst>
-              <a:gd name="adj" fmla="val 2286"/>
-            </a:avLst>
-          </a:prstGeom>
-          <a:solidFill>
-            <a:srgbClr val="FFFFFF"/>
-          </a:solidFill>
-          <a:ln w="12700">
-            <a:solidFill>
-              <a:srgbClr val="E2E8F0"/>
-            </a:solidFill>
-            <a:prstDash val="solid"/>
-          </a:ln>
-        </p:spPr>
-      </p:sp>
-      <p:sp>
-        <p:nvSpPr>
-          <p:cNvPr id="23" name="Text 17"/>
-          <p:cNvSpPr/>
-          <p:nvPr/>
-        </p:nvSpPr>
-        <p:spPr>
-          <a:xfrm>
-            <a:off x="8641080" y="1691640"/>
-            <a:ext cx="2880360" cy="4297680"/>
-          </a:xfrm>
-          <a:prstGeom prst="rect">
-            <a:avLst/>
-          </a:prstGeom>
-          <a:noFill/>
-          <a:ln/>
-        </p:spPr>
-        <p:txBody>
-          <a:bodyPr wrap="square" rtlCol="0" anchor="t"/>
-          <a:lstStyle/>
-          <a:p>
-            <a:pPr marL="342900" indent="-342900">
-              <a:lnSpc>
-                <a:spcPct val="115000"/>
-              </a:lnSpc>
-              <a:spcAft>
-                <a:spcPts val="800"/>
-              </a:spcAft>
-              <a:buSzPct val="100000"/>
-              <a:buChar char="●"/>
-            </a:pPr>
-            <a:r>
-              <a:rPr lang="en-US" sz="1400" dirty="0">
-                <a:solidFill>
-                  <a:srgbClr val="0F172A"/>
-                </a:solidFill>
-                <a:latin typeface="Microsoft YaHei" pitchFamily="34" charset="0"/>
-                <a:ea typeface="Microsoft YaHei" pitchFamily="34" charset="-122"/>
-                <a:cs typeface="Microsoft YaHei" pitchFamily="34" charset="-120"/>
-              </a:rPr>
-              <a:t>统一的设计令牌与组件库</a:t>
-            </a:r>
-            <a:endParaRPr lang="en-US" sz="1400" dirty="0"/>
-          </a:p>
-          <a:p>
-            <a:pPr marL="342900" indent="-342900">
-              <a:lnSpc>
-                <a:spcPct val="115000"/>
-              </a:lnSpc>
-              <a:spcAft>
-                <a:spcPts val="800"/>
-              </a:spcAft>
-              <a:buSzPct val="100000"/>
-              <a:buChar char="●"/>
-            </a:pPr>
-            <a:r>
-              <a:rPr lang="en-US" sz="1400" dirty="0">
-                <a:solidFill>
-                  <a:srgbClr val="0F172A"/>
-                </a:solidFill>
-                <a:latin typeface="Microsoft YaHei" pitchFamily="34" charset="0"/>
-                <a:ea typeface="Microsoft YaHei" pitchFamily="34" charset="-122"/>
-                <a:cs typeface="Microsoft YaHei" pitchFamily="34" charset="-120"/>
-              </a:rPr>
-              <a:t>亮 / 暗两套主题</a:t>
-            </a:r>
-            <a:endParaRPr lang="en-US" sz="1400" dirty="0"/>
-          </a:p>
-          <a:p>
-            <a:pPr marL="342900" indent="-342900">
-              <a:lnSpc>
-                <a:spcPct val="115000"/>
-              </a:lnSpc>
-              <a:spcAft>
-                <a:spcPts val="800"/>
-              </a:spcAft>
-              <a:buSzPct val="100000"/>
-              <a:buChar char="●"/>
-            </a:pPr>
-            <a:r>
-              <a:rPr lang="en-US" sz="1400" dirty="0">
-                <a:solidFill>
-                  <a:srgbClr val="0F172A"/>
-                </a:solidFill>
-                <a:latin typeface="Microsoft YaHei" pitchFamily="34" charset="0"/>
-                <a:ea typeface="Microsoft YaHei" pitchFamily="34" charset="-122"/>
-                <a:cs typeface="Microsoft YaHei" pitchFamily="34" charset="-120"/>
-              </a:rPr>
-              <a:t>1280 以下响应式布局</a:t>
-            </a:r>
-            <a:endParaRPr lang="en-US" sz="1400" dirty="0"/>
-          </a:p>
-          <a:p>
-            <a:pPr marL="342900" indent="-342900">
-              <a:lnSpc>
-                <a:spcPct val="115000"/>
-              </a:lnSpc>
-              <a:spcAft>
-                <a:spcPts val="800"/>
-              </a:spcAft>
-              <a:buSzPct val="100000"/>
-              <a:buChar char="●"/>
-            </a:pPr>
-            <a:r>
-              <a:rPr lang="en-US" sz="1400" dirty="0">
-                <a:solidFill>
-                  <a:srgbClr val="0F172A"/>
-                </a:solidFill>
-                <a:latin typeface="Microsoft YaHei" pitchFamily="34" charset="0"/>
-                <a:ea typeface="Microsoft YaHei" pitchFamily="34" charset="-122"/>
-                <a:cs typeface="Microsoft YaHei" pitchFamily="34" charset="-120"/>
-              </a:rPr>
-              <a:t>错误逐块降级，不整页白屏</a:t>
-            </a:r>
-            <a:endParaRPr lang="en-US" sz="1400" dirty="0"/>
-          </a:p>
-          <a:p>
-            <a:pPr marL="342900" indent="-342900">
-              <a:lnSpc>
-                <a:spcPct val="115000"/>
-              </a:lnSpc>
-              <a:spcAft>
-                <a:spcPts val="800"/>
-              </a:spcAft>
-              <a:buSzPct val="100000"/>
-              <a:buChar char="●"/>
-            </a:pPr>
-            <a:r>
-              <a:rPr lang="en-US" sz="1400" dirty="0">
-                <a:solidFill>
-                  <a:srgbClr val="0F172A"/>
-                </a:solidFill>
-                <a:latin typeface="Microsoft YaHei" pitchFamily="34" charset="0"/>
-                <a:ea typeface="Microsoft YaHei" pitchFamily="34" charset="-122"/>
-                <a:cs typeface="Microsoft YaHei" pitchFamily="34" charset="-120"/>
-              </a:rPr>
-              <a:t>15 组前端自检保证对比度、文案与交互</a:t>
-            </a:r>
-            <a:endParaRPr lang="en-US" sz="1400" dirty="0"/>
           </a:p>
         </p:txBody>
       </p:sp>

</xml_diff>